<commit_message>
Add GPU-hours to setup slide
Co-authored-by: Cursor <cursoragent@cursor.com>
</commit_message>
<xml_diff>
--- a/presentation/PowerSGD_reproduction.pptx
+++ b/presentation/PowerSGD_reproduction.pptx
@@ -10361,7 +10361,7 @@
         </p:nvGraphicFramePr>
         <p:xfrm>
           <a:off x="548640" y="1645920"/>
-          <a:ext cx="11064240" cy="3200400"/>
+          <a:ext cx="11064240" cy="3657600"/>
         </p:xfrm>
         <a:graphic>
           <a:graphicData uri="http://schemas.openxmlformats.org/drawingml/2006/table">
@@ -10829,6 +10829,71 @@
                   </a:tcPr>
                 </a:tc>
               </a:tr>
+              <a:tr h="457200">
+                <a:tc>
+                  <a:txBody>
+                    <a:bodyPr/>
+                    <a:lstStyle/>
+                    <a:p>
+                      <a:r>
+                        <a:rPr sz="1500" b="1">
+                          <a:solidFill>
+                            <a:srgbClr val="1B2A41"/>
+                          </a:solidFill>
+                        </a:rPr>
+                        <a:t>Compute used</a:t>
+                      </a:r>
+                    </a:p>
+                  </a:txBody>
+                  <a:tcPr>
+                    <a:solidFill>
+                      <a:srgbClr val="EEF3F7"/>
+                    </a:solidFill>
+                  </a:tcPr>
+                </a:tc>
+                <a:tc>
+                  <a:txBody>
+                    <a:bodyPr/>
+                    <a:lstStyle/>
+                    <a:p>
+                      <a:r>
+                        <a:rPr sz="1500" b="0">
+                          <a:solidFill>
+                            <a:srgbClr val="1B2A41"/>
+                          </a:solidFill>
+                        </a:rPr>
+                        <a:t>Not reported</a:t>
+                      </a:r>
+                    </a:p>
+                  </a:txBody>
+                  <a:tcPr>
+                    <a:solidFill>
+                      <a:srgbClr val="EEF3F7"/>
+                    </a:solidFill>
+                  </a:tcPr>
+                </a:tc>
+                <a:tc>
+                  <a:txBody>
+                    <a:bodyPr/>
+                    <a:lstStyle/>
+                    <a:p>
+                      <a:r>
+                        <a:rPr sz="1500" b="0">
+                          <a:solidFill>
+                            <a:srgbClr val="1B2A41"/>
+                          </a:solidFill>
+                        </a:rPr>
+                        <a:t>36.9 GPU-hours (from Slurm accounting)</a:t>
+                      </a:r>
+                    </a:p>
+                  </a:txBody>
+                  <a:tcPr>
+                    <a:solidFill>
+                      <a:srgbClr val="EEF3F7"/>
+                    </a:solidFill>
+                  </a:tcPr>
+                </a:tc>
+              </a:tr>
             </a:tbl>
           </a:graphicData>
         </a:graphic>
@@ -10841,8 +10906,8 @@
         </p:nvSpPr>
         <p:spPr>
           <a:xfrm>
-            <a:off x="548640" y="5074920"/>
-            <a:ext cx="10972800" cy="1280160"/>
+            <a:off x="548640" y="5349240"/>
+            <a:ext cx="10972800" cy="1005840"/>
           </a:xfrm>
           <a:prstGeom prst="rect">
             <a:avLst/>

</xml_diff>

<commit_message>
Add GPU utilization and memory from Slurm accounting
Co-authored-by: Cursor <cursoragent@cursor.com>
</commit_message>
<xml_diff>
--- a/presentation/PowerSGD_reproduction.pptx
+++ b/presentation/PowerSGD_reproduction.pptx
@@ -20,6 +20,7 @@
     <p:sldId id="268" r:id="rId20"/>
     <p:sldId id="269" r:id="rId21"/>
     <p:sldId id="270" r:id="rId22"/>
+    <p:sldId id="271" r:id="rId23"/>
   </p:sldIdLst>
   <p:sldSz cx="12191695" cy="6858000" type="screen4x3"/>
   <p:notesSz cx="6858000" cy="9144000"/>
@@ -796,7 +797,7 @@
           <a:lstStyle/>
           <a:p>
             <a:r>
-              <a:t>Summary of what reproduced. The algorithm behaves exactly as described; the wall-clock benefit depends on how expensive communication is relative to computation.</a:t>
+              <a:t>From Slurm accounting for each job. Utilization is the share of time any GPU kernel was running, including NCCL communication kernels, so it is not the same as useful compute. ResNet18 on 32x32 images with 128 images per GPU is too little work to keep an A100 busy. Both models fit in a few GB, which is why larger models such as nanoGPT are the next test.</a:t>
             </a:r>
           </a:p>
         </p:txBody>
@@ -866,7 +867,7 @@
           <a:lstStyle/>
           <a:p>
             <a:r>
-              <a:t>PowerSGD's speedup depends on the communication-to-compute ratio. Larger models such as GPT-style transformers send much bigger gradients, which is where we expect compression to pay off on modern hardware. That is the next part of the project.</a:t>
+              <a:t>Summary of what reproduced. The algorithm behaves exactly as described; the wall-clock benefit depends on how expensive communication is relative to computation.</a:t>
             </a:r>
           </a:p>
         </p:txBody>
@@ -892,6 +893,76 @@
 </file>
 
 <file path=ppt/notesSlides/notesSlide15.xml><?xml version="1.0" encoding="utf-8"?>
+<p:notes xmlns:a="http://schemas.openxmlformats.org/drawingml/2006/main" xmlns:p="http://schemas.openxmlformats.org/presentationml/2006/main" xmlns:r="http://schemas.openxmlformats.org/officeDocument/2006/relationships">
+  <p:cSld>
+    <p:spTree>
+      <p:nvGrpSpPr>
+        <p:cNvPr id="1" name=""/>
+        <p:cNvGrpSpPr/>
+        <p:nvPr/>
+      </p:nvGrpSpPr>
+      <p:grpSpPr>
+        <a:xfrm>
+          <a:off x="0" y="0"/>
+          <a:ext cx="0" cy="0"/>
+          <a:chOff x="0" y="0"/>
+          <a:chExt cx="0" cy="0"/>
+        </a:xfrm>
+      </p:grpSpPr>
+      <p:sp>
+        <p:nvSpPr>
+          <p:cNvPr id="2" name="Slide Image Placeholder 1"/>
+          <p:cNvSpPr>
+            <a:spLocks noGrp="1"/>
+          </p:cNvSpPr>
+          <p:nvPr>
+            <p:ph type="sldImg" idx="2"/>
+          </p:nvPr>
+        </p:nvSpPr>
+        <p:spPr/>
+      </p:sp>
+      <p:sp>
+        <p:nvSpPr>
+          <p:cNvPr id="3" name="Notes Placeholder 2"/>
+          <p:cNvSpPr>
+            <a:spLocks noGrp="1"/>
+          </p:cNvSpPr>
+          <p:nvPr>
+            <p:ph type="body" idx="3" sz="quarter"/>
+          </p:nvPr>
+        </p:nvSpPr>
+        <p:spPr/>
+        <p:txBody>
+          <a:bodyPr/>
+          <a:lstStyle/>
+          <a:p>
+            <a:r>
+              <a:t>PowerSGD's speedup depends on the communication-to-compute ratio. Larger models such as GPT-style transformers send much bigger gradients, which is where we expect compression to pay off on modern hardware. That is the next part of the project.</a:t>
+            </a:r>
+          </a:p>
+        </p:txBody>
+      </p:sp>
+      <p:sp>
+        <p:nvSpPr>
+          <p:cNvPr id="4" name="Slide Number Placeholder 3"/>
+          <p:cNvSpPr>
+            <a:spLocks noGrp="1"/>
+          </p:cNvSpPr>
+          <p:nvPr>
+            <p:ph type="sldNum" idx="5" sz="quarter"/>
+          </p:nvPr>
+        </p:nvSpPr>
+        <p:spPr/>
+      </p:sp>
+    </p:spTree>
+  </p:cSld>
+  <p:clrMapOvr>
+    <a:masterClrMapping/>
+  </p:clrMapOvr>
+</p:notes>
+</file>
+
+<file path=ppt/notesSlides/notesSlide16.xml><?xml version="1.0" encoding="utf-8"?>
 <p:notes xmlns:a="http://schemas.openxmlformats.org/drawingml/2006/main" xmlns:p="http://schemas.openxmlformats.org/presentationml/2006/main" xmlns:r="http://schemas.openxmlformats.org/officeDocument/2006/relationships">
   <p:cSld>
     <p:spTree>
@@ -5766,7 +5837,7 @@
                   <a:srgbClr val="1B2A41"/>
                 </a:solidFill>
               </a:rPr>
-              <a:t>Scorecard</a:t>
+              <a:t>GPU usage: these models are small for an A100</a:t>
             </a:r>
           </a:p>
         </p:txBody>
@@ -5800,7 +5871,7 @@
                   <a:srgbClr val="2E86AB"/>
                 </a:solidFill>
               </a:rPr>
-              <a:t>Accuracy and compression are properties of the algorithm; speedup depends on the hardware.</a:t>
+              <a:t>ResNet18 keeps the GPUs busy less than half the time; both models use under 11% of GPU memory.</a:t>
             </a:r>
           </a:p>
         </p:txBody>
@@ -5835,6 +5906,917 @@
                 </a:solidFill>
               </a:rPr>
               <a:t>13</a:t>
+            </a:r>
+          </a:p>
+        </p:txBody>
+      </p:sp>
+      <p:sp>
+        <p:nvSpPr>
+          <p:cNvPr id="6" name="TextBox 5"/>
+          <p:cNvSpPr txBox="1"/>
+          <p:nvPr/>
+        </p:nvSpPr>
+        <p:spPr>
+          <a:xfrm>
+            <a:off x="548640" y="6400800"/>
+            <a:ext cx="7315200" cy="365760"/>
+          </a:xfrm>
+          <a:prstGeom prst="rect">
+            <a:avLst/>
+          </a:prstGeom>
+          <a:noFill/>
+        </p:spPr>
+        <p:txBody>
+          <a:bodyPr wrap="square">
+            <a:spAutoFit/>
+          </a:bodyPr>
+          <a:lstStyle/>
+          <a:p>
+            <a:pPr algn="l"/>
+            <a:r>
+              <a:rPr sz="1200" b="0" i="0">
+                <a:solidFill>
+                  <a:srgbClr val="5C677D"/>
+                </a:solidFill>
+              </a:rPr>
+              <a:t>Reproducing PowerSGD on Perlmutter</a:t>
+            </a:r>
+          </a:p>
+        </p:txBody>
+      </p:sp>
+      <p:graphicFrame>
+        <p:nvGraphicFramePr>
+          <p:cNvPr id="7" name="Table 6"/>
+          <p:cNvGraphicFramePr>
+            <a:graphicFrameLocks noGrp="1"/>
+          </p:cNvGraphicFramePr>
+          <p:nvPr/>
+        </p:nvGraphicFramePr>
+        <p:xfrm>
+          <a:off x="548640" y="1645920"/>
+          <a:ext cx="11064240" cy="2286000"/>
+        </p:xfrm>
+        <a:graphic>
+          <a:graphicData uri="http://schemas.openxmlformats.org/drawingml/2006/table">
+            <a:tbl>
+              <a:tblPr firstRow="1" bandRow="1">
+                <a:tableStyleId>{5C22544A-7EE6-4342-B048-85BDC9FD1C3A}</a:tableStyleId>
+              </a:tblPr>
+              <a:tblGrid>
+                <a:gridCol w="1737360"/>
+                <a:gridCol w="2377440"/>
+                <a:gridCol w="2194560"/>
+                <a:gridCol w="2377440"/>
+                <a:gridCol w="2377440"/>
+              </a:tblGrid>
+              <a:tr h="457200">
+                <a:tc>
+                  <a:txBody>
+                    <a:bodyPr/>
+                    <a:lstStyle/>
+                    <a:p>
+                      <a:r>
+                        <a:rPr sz="1600" b="1">
+                          <a:solidFill>
+                            <a:srgbClr val="FFFFFF"/>
+                          </a:solidFill>
+                        </a:rPr>
+                        <a:t>Method</a:t>
+                      </a:r>
+                    </a:p>
+                  </a:txBody>
+                  <a:tcPr>
+                    <a:solidFill>
+                      <a:srgbClr val="1B2A41"/>
+                    </a:solidFill>
+                  </a:tcPr>
+                </a:tc>
+                <a:tc>
+                  <a:txBody>
+                    <a:bodyPr/>
+                    <a:lstStyle/>
+                    <a:p>
+                      <a:r>
+                        <a:rPr sz="1600" b="1">
+                          <a:solidFill>
+                            <a:srgbClr val="FFFFFF"/>
+                          </a:solidFill>
+                        </a:rPr>
+                        <a:t>ResNet18: GPU busy</a:t>
+                      </a:r>
+                    </a:p>
+                  </a:txBody>
+                  <a:tcPr>
+                    <a:solidFill>
+                      <a:srgbClr val="1B2A41"/>
+                    </a:solidFill>
+                  </a:tcPr>
+                </a:tc>
+                <a:tc>
+                  <a:txBody>
+                    <a:bodyPr/>
+                    <a:lstStyle/>
+                    <a:p>
+                      <a:r>
+                        <a:rPr sz="1600" b="1">
+                          <a:solidFill>
+                            <a:srgbClr val="FFFFFF"/>
+                          </a:solidFill>
+                        </a:rPr>
+                        <a:t>ResNet18: memory</a:t>
+                      </a:r>
+                    </a:p>
+                  </a:txBody>
+                  <a:tcPr>
+                    <a:solidFill>
+                      <a:srgbClr val="1B2A41"/>
+                    </a:solidFill>
+                  </a:tcPr>
+                </a:tc>
+                <a:tc>
+                  <a:txBody>
+                    <a:bodyPr/>
+                    <a:lstStyle/>
+                    <a:p>
+                      <a:r>
+                        <a:rPr sz="1600" b="1">
+                          <a:solidFill>
+                            <a:srgbClr val="FFFFFF"/>
+                          </a:solidFill>
+                        </a:rPr>
+                        <a:t>LSTM: GPU busy</a:t>
+                      </a:r>
+                    </a:p>
+                  </a:txBody>
+                  <a:tcPr>
+                    <a:solidFill>
+                      <a:srgbClr val="1B2A41"/>
+                    </a:solidFill>
+                  </a:tcPr>
+                </a:tc>
+                <a:tc>
+                  <a:txBody>
+                    <a:bodyPr/>
+                    <a:lstStyle/>
+                    <a:p>
+                      <a:r>
+                        <a:rPr sz="1600" b="1">
+                          <a:solidFill>
+                            <a:srgbClr val="FFFFFF"/>
+                          </a:solidFill>
+                        </a:rPr>
+                        <a:t>LSTM: memory</a:t>
+                      </a:r>
+                    </a:p>
+                  </a:txBody>
+                  <a:tcPr>
+                    <a:solidFill>
+                      <a:srgbClr val="1B2A41"/>
+                    </a:solidFill>
+                  </a:tcPr>
+                </a:tc>
+              </a:tr>
+              <a:tr h="457200">
+                <a:tc>
+                  <a:txBody>
+                    <a:bodyPr/>
+                    <a:lstStyle/>
+                    <a:p>
+                      <a:r>
+                        <a:rPr sz="1600" b="1">
+                          <a:solidFill>
+                            <a:srgbClr val="1B2A41"/>
+                          </a:solidFill>
+                        </a:rPr>
+                        <a:t>SGD</a:t>
+                      </a:r>
+                    </a:p>
+                  </a:txBody>
+                  <a:tcPr>
+                    <a:solidFill>
+                      <a:srgbClr val="EEF3F7"/>
+                    </a:solidFill>
+                  </a:tcPr>
+                </a:tc>
+                <a:tc>
+                  <a:txBody>
+                    <a:bodyPr/>
+                    <a:lstStyle/>
+                    <a:p>
+                      <a:r>
+                        <a:rPr sz="1600" b="0">
+                          <a:solidFill>
+                            <a:srgbClr val="1B2A41"/>
+                          </a:solidFill>
+                        </a:rPr>
+                        <a:t>43-48%</a:t>
+                      </a:r>
+                    </a:p>
+                  </a:txBody>
+                  <a:tcPr>
+                    <a:solidFill>
+                      <a:srgbClr val="EEF3F7"/>
+                    </a:solidFill>
+                  </a:tcPr>
+                </a:tc>
+                <a:tc>
+                  <a:txBody>
+                    <a:bodyPr/>
+                    <a:lstStyle/>
+                    <a:p>
+                      <a:r>
+                        <a:rPr sz="1600" b="0">
+                          <a:solidFill>
+                            <a:srgbClr val="1B2A41"/>
+                          </a:solidFill>
+                        </a:rPr>
+                        <a:t>2.6 GB</a:t>
+                      </a:r>
+                    </a:p>
+                  </a:txBody>
+                  <a:tcPr>
+                    <a:solidFill>
+                      <a:srgbClr val="EEF3F7"/>
+                    </a:solidFill>
+                  </a:tcPr>
+                </a:tc>
+                <a:tc>
+                  <a:txBody>
+                    <a:bodyPr/>
+                    <a:lstStyle/>
+                    <a:p>
+                      <a:r>
+                        <a:rPr sz="1600" b="0">
+                          <a:solidFill>
+                            <a:srgbClr val="1B2A41"/>
+                          </a:solidFill>
+                        </a:rPr>
+                        <a:t>96%*</a:t>
+                      </a:r>
+                    </a:p>
+                  </a:txBody>
+                  <a:tcPr>
+                    <a:solidFill>
+                      <a:srgbClr val="EEF3F7"/>
+                    </a:solidFill>
+                  </a:tcPr>
+                </a:tc>
+                <a:tc>
+                  <a:txBody>
+                    <a:bodyPr/>
+                    <a:lstStyle/>
+                    <a:p>
+                      <a:r>
+                        <a:rPr sz="1600" b="0">
+                          <a:solidFill>
+                            <a:srgbClr val="1B2A41"/>
+                          </a:solidFill>
+                        </a:rPr>
+                        <a:t>4.2 GB*</a:t>
+                      </a:r>
+                    </a:p>
+                  </a:txBody>
+                  <a:tcPr>
+                    <a:solidFill>
+                      <a:srgbClr val="EEF3F7"/>
+                    </a:solidFill>
+                  </a:tcPr>
+                </a:tc>
+              </a:tr>
+              <a:tr h="457200">
+                <a:tc>
+                  <a:txBody>
+                    <a:bodyPr/>
+                    <a:lstStyle/>
+                    <a:p>
+                      <a:r>
+                        <a:rPr sz="1600" b="1">
+                          <a:solidFill>
+                            <a:srgbClr val="1B2A41"/>
+                          </a:solidFill>
+                        </a:rPr>
+                        <a:t>Rank 1</a:t>
+                      </a:r>
+                    </a:p>
+                  </a:txBody>
+                  <a:tcPr>
+                    <a:solidFill>
+                      <a:srgbClr val="FFFFFF"/>
+                    </a:solidFill>
+                  </a:tcPr>
+                </a:tc>
+                <a:tc>
+                  <a:txBody>
+                    <a:bodyPr/>
+                    <a:lstStyle/>
+                    <a:p>
+                      <a:r>
+                        <a:rPr sz="1600" b="0">
+                          <a:solidFill>
+                            <a:srgbClr val="1B2A41"/>
+                          </a:solidFill>
+                        </a:rPr>
+                        <a:t>44-45%</a:t>
+                      </a:r>
+                    </a:p>
+                  </a:txBody>
+                  <a:tcPr>
+                    <a:solidFill>
+                      <a:srgbClr val="FFFFFF"/>
+                    </a:solidFill>
+                  </a:tcPr>
+                </a:tc>
+                <a:tc>
+                  <a:txBody>
+                    <a:bodyPr/>
+                    <a:lstStyle/>
+                    <a:p>
+                      <a:r>
+                        <a:rPr sz="1600" b="0">
+                          <a:solidFill>
+                            <a:srgbClr val="1B2A41"/>
+                          </a:solidFill>
+                        </a:rPr>
+                        <a:t>2.5 GB</a:t>
+                      </a:r>
+                    </a:p>
+                  </a:txBody>
+                  <a:tcPr>
+                    <a:solidFill>
+                      <a:srgbClr val="FFFFFF"/>
+                    </a:solidFill>
+                  </a:tcPr>
+                </a:tc>
+                <a:tc>
+                  <a:txBody>
+                    <a:bodyPr/>
+                    <a:lstStyle/>
+                    <a:p>
+                      <a:r>
+                        <a:rPr sz="1600" b="0">
+                          <a:solidFill>
+                            <a:srgbClr val="1B2A41"/>
+                          </a:solidFill>
+                        </a:rPr>
+                        <a:t>96%</a:t>
+                      </a:r>
+                    </a:p>
+                  </a:txBody>
+                  <a:tcPr>
+                    <a:solidFill>
+                      <a:srgbClr val="FFFFFF"/>
+                    </a:solidFill>
+                  </a:tcPr>
+                </a:tc>
+                <a:tc>
+                  <a:txBody>
+                    <a:bodyPr/>
+                    <a:lstStyle/>
+                    <a:p>
+                      <a:r>
+                        <a:rPr sz="1600" b="0">
+                          <a:solidFill>
+                            <a:srgbClr val="1B2A41"/>
+                          </a:solidFill>
+                        </a:rPr>
+                        <a:t>4.1 GB</a:t>
+                      </a:r>
+                    </a:p>
+                  </a:txBody>
+                  <a:tcPr>
+                    <a:solidFill>
+                      <a:srgbClr val="FFFFFF"/>
+                    </a:solidFill>
+                  </a:tcPr>
+                </a:tc>
+              </a:tr>
+              <a:tr h="457200">
+                <a:tc>
+                  <a:txBody>
+                    <a:bodyPr/>
+                    <a:lstStyle/>
+                    <a:p>
+                      <a:r>
+                        <a:rPr sz="1600" b="1">
+                          <a:solidFill>
+                            <a:srgbClr val="1B2A41"/>
+                          </a:solidFill>
+                        </a:rPr>
+                        <a:t>Rank 2</a:t>
+                      </a:r>
+                    </a:p>
+                  </a:txBody>
+                  <a:tcPr>
+                    <a:solidFill>
+                      <a:srgbClr val="EEF3F7"/>
+                    </a:solidFill>
+                  </a:tcPr>
+                </a:tc>
+                <a:tc>
+                  <a:txBody>
+                    <a:bodyPr/>
+                    <a:lstStyle/>
+                    <a:p>
+                      <a:r>
+                        <a:rPr sz="1600" b="0">
+                          <a:solidFill>
+                            <a:srgbClr val="1B2A41"/>
+                          </a:solidFill>
+                        </a:rPr>
+                        <a:t>46%</a:t>
+                      </a:r>
+                    </a:p>
+                  </a:txBody>
+                  <a:tcPr>
+                    <a:solidFill>
+                      <a:srgbClr val="EEF3F7"/>
+                    </a:solidFill>
+                  </a:tcPr>
+                </a:tc>
+                <a:tc>
+                  <a:txBody>
+                    <a:bodyPr/>
+                    <a:lstStyle/>
+                    <a:p>
+                      <a:r>
+                        <a:rPr sz="1600" b="0">
+                          <a:solidFill>
+                            <a:srgbClr val="1B2A41"/>
+                          </a:solidFill>
+                        </a:rPr>
+                        <a:t>2.5 GB</a:t>
+                      </a:r>
+                    </a:p>
+                  </a:txBody>
+                  <a:tcPr>
+                    <a:solidFill>
+                      <a:srgbClr val="EEF3F7"/>
+                    </a:solidFill>
+                  </a:tcPr>
+                </a:tc>
+                <a:tc>
+                  <a:txBody>
+                    <a:bodyPr/>
+                    <a:lstStyle/>
+                    <a:p>
+                      <a:r>
+                        <a:rPr sz="1600" b="0">
+                          <a:solidFill>
+                            <a:srgbClr val="1B2A41"/>
+                          </a:solidFill>
+                        </a:rPr>
+                        <a:t>96%</a:t>
+                      </a:r>
+                    </a:p>
+                  </a:txBody>
+                  <a:tcPr>
+                    <a:solidFill>
+                      <a:srgbClr val="EEF3F7"/>
+                    </a:solidFill>
+                  </a:tcPr>
+                </a:tc>
+                <a:tc>
+                  <a:txBody>
+                    <a:bodyPr/>
+                    <a:lstStyle/>
+                    <a:p>
+                      <a:r>
+                        <a:rPr sz="1600" b="0">
+                          <a:solidFill>
+                            <a:srgbClr val="1B2A41"/>
+                          </a:solidFill>
+                        </a:rPr>
+                        <a:t>4.2 GB</a:t>
+                      </a:r>
+                    </a:p>
+                  </a:txBody>
+                  <a:tcPr>
+                    <a:solidFill>
+                      <a:srgbClr val="EEF3F7"/>
+                    </a:solidFill>
+                  </a:tcPr>
+                </a:tc>
+              </a:tr>
+              <a:tr h="457200">
+                <a:tc>
+                  <a:txBody>
+                    <a:bodyPr/>
+                    <a:lstStyle/>
+                    <a:p>
+                      <a:r>
+                        <a:rPr sz="1600" b="1">
+                          <a:solidFill>
+                            <a:srgbClr val="1B2A41"/>
+                          </a:solidFill>
+                        </a:rPr>
+                        <a:t>Rank 4</a:t>
+                      </a:r>
+                    </a:p>
+                  </a:txBody>
+                  <a:tcPr>
+                    <a:solidFill>
+                      <a:srgbClr val="FFFFFF"/>
+                    </a:solidFill>
+                  </a:tcPr>
+                </a:tc>
+                <a:tc>
+                  <a:txBody>
+                    <a:bodyPr/>
+                    <a:lstStyle/>
+                    <a:p>
+                      <a:r>
+                        <a:rPr sz="1600" b="0">
+                          <a:solidFill>
+                            <a:srgbClr val="1B2A41"/>
+                          </a:solidFill>
+                        </a:rPr>
+                        <a:t>46-48%</a:t>
+                      </a:r>
+                    </a:p>
+                  </a:txBody>
+                  <a:tcPr>
+                    <a:solidFill>
+                      <a:srgbClr val="FFFFFF"/>
+                    </a:solidFill>
+                  </a:tcPr>
+                </a:tc>
+                <a:tc>
+                  <a:txBody>
+                    <a:bodyPr/>
+                    <a:lstStyle/>
+                    <a:p>
+                      <a:r>
+                        <a:rPr sz="1600" b="0">
+                          <a:solidFill>
+                            <a:srgbClr val="1B2A41"/>
+                          </a:solidFill>
+                        </a:rPr>
+                        <a:t>2.5 GB</a:t>
+                      </a:r>
+                    </a:p>
+                  </a:txBody>
+                  <a:tcPr>
+                    <a:solidFill>
+                      <a:srgbClr val="FFFFFF"/>
+                    </a:solidFill>
+                  </a:tcPr>
+                </a:tc>
+                <a:tc>
+                  <a:txBody>
+                    <a:bodyPr/>
+                    <a:lstStyle/>
+                    <a:p>
+                      <a:r>
+                        <a:rPr sz="1600" b="0">
+                          <a:solidFill>
+                            <a:srgbClr val="1B2A41"/>
+                          </a:solidFill>
+                        </a:rPr>
+                        <a:t>95%</a:t>
+                      </a:r>
+                    </a:p>
+                  </a:txBody>
+                  <a:tcPr>
+                    <a:solidFill>
+                      <a:srgbClr val="FFFFFF"/>
+                    </a:solidFill>
+                  </a:tcPr>
+                </a:tc>
+                <a:tc>
+                  <a:txBody>
+                    <a:bodyPr/>
+                    <a:lstStyle/>
+                    <a:p>
+                      <a:r>
+                        <a:rPr sz="1600" b="0">
+                          <a:solidFill>
+                            <a:srgbClr val="1B2A41"/>
+                          </a:solidFill>
+                        </a:rPr>
+                        <a:t>4.1 GB</a:t>
+                      </a:r>
+                    </a:p>
+                  </a:txBody>
+                  <a:tcPr>
+                    <a:solidFill>
+                      <a:srgbClr val="FFFFFF"/>
+                    </a:solidFill>
+                  </a:tcPr>
+                </a:tc>
+              </a:tr>
+            </a:tbl>
+          </a:graphicData>
+        </a:graphic>
+      </p:graphicFrame>
+      <p:sp>
+        <p:nvSpPr>
+          <p:cNvPr id="8" name="TextBox 7"/>
+          <p:cNvSpPr txBox="1"/>
+          <p:nvPr/>
+        </p:nvSpPr>
+        <p:spPr>
+          <a:xfrm>
+            <a:off x="548640" y="4160520"/>
+            <a:ext cx="11155680" cy="2194560"/>
+          </a:xfrm>
+          <a:prstGeom prst="rect">
+            <a:avLst/>
+          </a:prstGeom>
+          <a:noFill/>
+        </p:spPr>
+        <p:txBody>
+          <a:bodyPr wrap="square">
+            <a:spAutoFit/>
+          </a:bodyPr>
+          <a:lstStyle/>
+          <a:p>
+            <a:pPr>
+              <a:spcAft>
+                <a:spcPts val="800"/>
+              </a:spcAft>
+            </a:pPr>
+            <a:r>
+              <a:rPr sz="1500" b="1">
+                <a:solidFill>
+                  <a:srgbClr val="2E86AB"/>
+                </a:solidFill>
+              </a:rPr>
+              <a:t>•  </a:t>
+            </a:r>
+            <a:r>
+              <a:rPr sz="1500" b="1">
+                <a:solidFill>
+                  <a:srgbClr val="1B2A41"/>
+                </a:solidFill>
+              </a:rPr>
+              <a:t>GPU busy </a:t>
+            </a:r>
+            <a:r>
+              <a:rPr sz="1500">
+                <a:solidFill>
+                  <a:srgbClr val="1B2A41"/>
+                </a:solidFill>
+              </a:rPr>
+              <a:t>= average share of time a kernel was running (Slurm/NVML), over all 16 GPUs and the whole run. Communication kernels count as busy, so this is not useful-compute efficiency.</a:t>
+            </a:r>
+          </a:p>
+          <a:p>
+            <a:pPr>
+              <a:spcAft>
+                <a:spcPts val="800"/>
+              </a:spcAft>
+            </a:pPr>
+            <a:r>
+              <a:rPr sz="1500" b="1">
+                <a:solidFill>
+                  <a:srgbClr val="2E86AB"/>
+                </a:solidFill>
+              </a:rPr>
+              <a:t>•  </a:t>
+            </a:r>
+            <a:r>
+              <a:rPr sz="1500" b="1">
+                <a:solidFill>
+                  <a:srgbClr val="1B2A41"/>
+                </a:solidFill>
+              </a:rPr>
+              <a:t>ResNet18 leaves the A100s idle more than half the time: </a:t>
+            </a:r>
+            <a:r>
+              <a:rPr sz="1500">
+                <a:solidFill>
+                  <a:srgbClr val="1B2A41"/>
+                </a:solidFill>
+              </a:rPr>
+              <a:t>128 small images per GPU per step is too little work, so launch overhead, data loading and synchronization dominate.</a:t>
+            </a:r>
+          </a:p>
+          <a:p>
+            <a:pPr>
+              <a:spcAft>
+                <a:spcPts val="800"/>
+              </a:spcAft>
+            </a:pPr>
+            <a:r>
+              <a:rPr sz="1500" b="1">
+                <a:solidFill>
+                  <a:srgbClr val="2E86AB"/>
+                </a:solidFill>
+              </a:rPr>
+              <a:t>•  </a:t>
+            </a:r>
+            <a:r>
+              <a:rPr sz="1500" b="1">
+                <a:solidFill>
+                  <a:srgbClr val="1B2A41"/>
+                </a:solidFill>
+              </a:rPr>
+              <a:t>Memory: </a:t>
+            </a:r>
+            <a:r>
+              <a:rPr sz="1500">
+                <a:solidFill>
+                  <a:srgbClr val="1B2A41"/>
+                </a:solidFill>
+              </a:rPr>
+              <a:t>2.5-4.2 GB of 40 GB per GPU. Larger models are where gradient compression should matter.</a:t>
+            </a:r>
+          </a:p>
+        </p:txBody>
+      </p:sp>
+      <p:sp>
+        <p:nvSpPr>
+          <p:cNvPr id="9" name="TextBox 8"/>
+          <p:cNvSpPr txBox="1"/>
+          <p:nvPr/>
+        </p:nvSpPr>
+        <p:spPr>
+          <a:xfrm>
+            <a:off x="548640" y="6035040"/>
+            <a:ext cx="11064240" cy="365760"/>
+          </a:xfrm>
+          <a:prstGeom prst="rect">
+            <a:avLst/>
+          </a:prstGeom>
+          <a:noFill/>
+        </p:spPr>
+        <p:txBody>
+          <a:bodyPr wrap="square">
+            <a:spAutoFit/>
+          </a:bodyPr>
+          <a:lstStyle/>
+          <a:p>
+            <a:pPr algn="l"/>
+            <a:r>
+              <a:rPr sz="1200" b="0" i="1">
+                <a:solidFill>
+                  <a:srgbClr val="5C677D"/>
+                </a:solidFill>
+              </a:rPr>
+              <a:t>* 2 of 3 seeds; Slurm has no GPU record for LSTM SGD seed 3. Per-job values: results/paper_reproduction/gpu_usage.txt</a:t>
+            </a:r>
+          </a:p>
+        </p:txBody>
+      </p:sp>
+    </p:spTree>
+  </p:cSld>
+  <p:clrMapOvr>
+    <a:masterClrMapping/>
+  </p:clrMapOvr>
+</p:sld>
+</file>
+
+<file path=ppt/slides/slide14.xml><?xml version="1.0" encoding="utf-8"?>
+<p:sld xmlns:a="http://schemas.openxmlformats.org/drawingml/2006/main" xmlns:p="http://schemas.openxmlformats.org/presentationml/2006/main" xmlns:r="http://schemas.openxmlformats.org/officeDocument/2006/relationships">
+  <p:cSld>
+    <p:spTree>
+      <p:nvGrpSpPr>
+        <p:cNvPr id="1" name=""/>
+        <p:cNvGrpSpPr/>
+        <p:nvPr/>
+      </p:nvGrpSpPr>
+      <p:grpSpPr/>
+      <p:sp>
+        <p:nvSpPr>
+          <p:cNvPr id="2" name="Rectangle 1"/>
+          <p:cNvSpPr/>
+          <p:nvPr/>
+        </p:nvSpPr>
+        <p:spPr>
+          <a:xfrm>
+            <a:off x="0" y="0"/>
+            <a:ext cx="164592" cy="6858000"/>
+          </a:xfrm>
+          <a:prstGeom prst="rect">
+            <a:avLst/>
+          </a:prstGeom>
+          <a:solidFill>
+            <a:srgbClr val="2E86AB"/>
+          </a:solidFill>
+          <a:ln>
+            <a:noFill/>
+          </a:ln>
+        </p:spPr>
+        <p:style>
+          <a:lnRef idx="1">
+            <a:schemeClr val="accent1"/>
+          </a:lnRef>
+          <a:fillRef idx="3">
+            <a:schemeClr val="accent1"/>
+          </a:fillRef>
+          <a:effectRef idx="2">
+            <a:schemeClr val="accent1"/>
+          </a:effectRef>
+          <a:fontRef idx="minor">
+            <a:schemeClr val="lt1"/>
+          </a:fontRef>
+        </p:style>
+        <p:txBody>
+          <a:bodyPr rtlCol="0" anchor="ctr"/>
+          <a:lstStyle/>
+          <a:p>
+            <a:pPr algn="ctr"/>
+          </a:p>
+        </p:txBody>
+      </p:sp>
+      <p:sp>
+        <p:nvSpPr>
+          <p:cNvPr id="3" name="TextBox 2"/>
+          <p:cNvSpPr txBox="1"/>
+          <p:nvPr/>
+        </p:nvSpPr>
+        <p:spPr>
+          <a:xfrm>
+            <a:off x="548640" y="274320"/>
+            <a:ext cx="11155680" cy="731520"/>
+          </a:xfrm>
+          <a:prstGeom prst="rect">
+            <a:avLst/>
+          </a:prstGeom>
+          <a:noFill/>
+        </p:spPr>
+        <p:txBody>
+          <a:bodyPr wrap="square">
+            <a:spAutoFit/>
+          </a:bodyPr>
+          <a:lstStyle/>
+          <a:p>
+            <a:pPr algn="l"/>
+            <a:r>
+              <a:rPr sz="3000" b="1" i="0">
+                <a:solidFill>
+                  <a:srgbClr val="1B2A41"/>
+                </a:solidFill>
+              </a:rPr>
+              <a:t>Scorecard</a:t>
+            </a:r>
+          </a:p>
+        </p:txBody>
+      </p:sp>
+      <p:sp>
+        <p:nvSpPr>
+          <p:cNvPr id="4" name="TextBox 3"/>
+          <p:cNvSpPr txBox="1"/>
+          <p:nvPr/>
+        </p:nvSpPr>
+        <p:spPr>
+          <a:xfrm>
+            <a:off x="548640" y="914400"/>
+            <a:ext cx="11155680" cy="548640"/>
+          </a:xfrm>
+          <a:prstGeom prst="rect">
+            <a:avLst/>
+          </a:prstGeom>
+          <a:noFill/>
+        </p:spPr>
+        <p:txBody>
+          <a:bodyPr wrap="square">
+            <a:spAutoFit/>
+          </a:bodyPr>
+          <a:lstStyle/>
+          <a:p>
+            <a:pPr algn="l"/>
+            <a:r>
+              <a:rPr sz="1900" b="1" i="0">
+                <a:solidFill>
+                  <a:srgbClr val="2E86AB"/>
+                </a:solidFill>
+              </a:rPr>
+              <a:t>Accuracy and compression are properties of the algorithm; speedup depends on the hardware.</a:t>
+            </a:r>
+          </a:p>
+        </p:txBody>
+      </p:sp>
+      <p:sp>
+        <p:nvSpPr>
+          <p:cNvPr id="5" name="TextBox 4"/>
+          <p:cNvSpPr txBox="1"/>
+          <p:nvPr/>
+        </p:nvSpPr>
+        <p:spPr>
+          <a:xfrm>
+            <a:off x="10881360" y="6400800"/>
+            <a:ext cx="1005840" cy="365760"/>
+          </a:xfrm>
+          <a:prstGeom prst="rect">
+            <a:avLst/>
+          </a:prstGeom>
+          <a:noFill/>
+        </p:spPr>
+        <p:txBody>
+          <a:bodyPr wrap="square">
+            <a:spAutoFit/>
+          </a:bodyPr>
+          <a:lstStyle/>
+          <a:p>
+            <a:pPr algn="r"/>
+            <a:r>
+              <a:rPr sz="1200" b="0" i="0">
+                <a:solidFill>
+                  <a:srgbClr val="5C677D"/>
+                </a:solidFill>
+              </a:rPr>
+              <a:t>14</a:t>
             </a:r>
           </a:p>
         </p:txBody>
@@ -6511,7 +7493,7 @@
 </p:sld>
 </file>
 
-<file path=ppt/slides/slide14.xml><?xml version="1.0" encoding="utf-8"?>
+<file path=ppt/slides/slide15.xml><?xml version="1.0" encoding="utf-8"?>
 <p:sld xmlns:a="http://schemas.openxmlformats.org/drawingml/2006/main" xmlns:p="http://schemas.openxmlformats.org/presentationml/2006/main" xmlns:r="http://schemas.openxmlformats.org/officeDocument/2006/relationships">
   <p:cSld>
     <p:spTree>
@@ -6627,7 +7609,7 @@
                   <a:srgbClr val="5C677D"/>
                 </a:solidFill>
               </a:rPr>
-              <a:t>14</a:t>
+              <a:t>15</a:t>
             </a:r>
           </a:p>
         </p:txBody>
@@ -6981,7 +7963,7 @@
 </p:sld>
 </file>
 
-<file path=ppt/slides/slide15.xml><?xml version="1.0" encoding="utf-8"?>
+<file path=ppt/slides/slide16.xml><?xml version="1.0" encoding="utf-8"?>
 <p:sld xmlns:a="http://schemas.openxmlformats.org/drawingml/2006/main" xmlns:p="http://schemas.openxmlformats.org/presentationml/2006/main" xmlns:r="http://schemas.openxmlformats.org/officeDocument/2006/relationships">
   <p:cSld>
     <p:spTree>
@@ -7131,7 +8113,7 @@
                   <a:srgbClr val="5C677D"/>
                 </a:solidFill>
               </a:rPr>
-              <a:t>15</a:t>
+              <a:t>16</a:t>
             </a:r>
           </a:p>
         </p:txBody>

</xml_diff>